<commit_message>
updated code/slides for module 1, class 2,3,4,5
</commit_message>
<xml_diff>
--- a/Module 1/class_1.4/deep_learning_course_class_1.4.pptx
+++ b/Module 1/class_1.4/deep_learning_course_class_1.4.pptx
@@ -26,7 +26,6 @@
     <p:sldId id="271" r:id="rId21"/>
     <p:sldId id="272" r:id="rId22"/>
     <p:sldId id="273" r:id="rId23"/>
-    <p:sldId id="274" r:id="rId24"/>
   </p:sldIdLst>
   <p:sldSz cy="5143500" cx="9144000"/>
   <p:notesSz cx="6858000" cy="9144000"/>
@@ -1650,105 +1649,6 @@
       <p:sp>
         <p:nvSpPr>
           <p:cNvPr id="233" name="Google Shape;233;g37426365403_0_11:notes"/>
-          <p:cNvSpPr txBox="1"/>
-          <p:nvPr>
-            <p:ph idx="1" type="body"/>
-          </p:nvPr>
-        </p:nvSpPr>
-        <p:spPr>
-          <a:xfrm>
-            <a:off x="685800" y="4343400"/>
-            <a:ext cx="5486400" cy="4114800"/>
-          </a:xfrm>
-          <a:prstGeom prst="rect">
-            <a:avLst/>
-          </a:prstGeom>
-        </p:spPr>
-        <p:txBody>
-          <a:bodyPr anchorCtr="0" anchor="t" bIns="91425" lIns="91425" spcFirstLastPara="1" rIns="91425" wrap="square" tIns="91425">
-            <a:noAutofit/>
-          </a:bodyPr>
-          <a:lstStyle/>
-          <a:p>
-            <a:pPr indent="0" lvl="0" marL="0" rtl="0" algn="l">
-              <a:spcBef>
-                <a:spcPts val="0"/>
-              </a:spcBef>
-              <a:spcAft>
-                <a:spcPts val="0"/>
-              </a:spcAft>
-              <a:buNone/>
-            </a:pPr>
-            <a:r>
-              <a:t/>
-            </a:r>
-            <a:endParaRPr/>
-          </a:p>
-        </p:txBody>
-      </p:sp>
-    </p:spTree>
-  </p:cSld>
-  <p:clrMapOvr>
-    <a:masterClrMapping/>
-  </p:clrMapOvr>
-</p:notes>
-</file>
-
-<file path=ppt/notesSlides/notesSlide19.xml><?xml version="1.0" encoding="utf-8"?>
-<p:notes xmlns:a="http://schemas.openxmlformats.org/drawingml/2006/main" xmlns:r="http://schemas.openxmlformats.org/officeDocument/2006/relationships" xmlns:mc="http://schemas.openxmlformats.org/markup-compatibility/2006" xmlns:mv="urn:schemas-microsoft-com:mac:vml" xmlns:p="http://schemas.openxmlformats.org/presentationml/2006/main" xmlns:c="http://schemas.openxmlformats.org/drawingml/2006/chart" xmlns:dgm="http://schemas.openxmlformats.org/drawingml/2006/diagram" xmlns:o="urn:schemas-microsoft-com:office:office" xmlns:v="urn:schemas-microsoft-com:vml" xmlns:pvml="urn:schemas-microsoft-com:office:powerpoint" xmlns:com="http://schemas.openxmlformats.org/drawingml/2006/compatibility" xmlns:p14="http://schemas.microsoft.com/office/powerpoint/2010/main" xmlns:p15="http://schemas.microsoft.com/office/powerpoint/2012/main" xmlns:ahyp="http://schemas.microsoft.com/office/drawing/2018/hyperlinkcolor" showMasterPhAnim="0" showMasterSp="0">
-  <p:cSld>
-    <p:spTree>
-      <p:nvGrpSpPr>
-        <p:cNvPr id="265" name="Shape 265"/>
-        <p:cNvGrpSpPr/>
-        <p:nvPr/>
-      </p:nvGrpSpPr>
-      <p:grpSpPr>
-        <a:xfrm>
-          <a:off x="0" y="0"/>
-          <a:ext cx="0" cy="0"/>
-          <a:chOff x="0" y="0"/>
-          <a:chExt cx="0" cy="0"/>
-        </a:xfrm>
-      </p:grpSpPr>
-      <p:sp>
-        <p:nvSpPr>
-          <p:cNvPr id="266" name="Google Shape;266;g38bdd1193af_0_53:notes"/>
-          <p:cNvSpPr/>
-          <p:nvPr>
-            <p:ph idx="2" type="sldImg"/>
-          </p:nvPr>
-        </p:nvSpPr>
-        <p:spPr>
-          <a:xfrm>
-            <a:off x="381300" y="685800"/>
-            <a:ext cx="6096000" cy="3429000"/>
-          </a:xfrm>
-          <a:custGeom>
-            <a:rect b="b" l="l" r="r" t="t"/>
-            <a:pathLst>
-              <a:path extrusionOk="0" h="120000" w="120000">
-                <a:moveTo>
-                  <a:pt x="0" y="0"/>
-                </a:moveTo>
-                <a:lnTo>
-                  <a:pt x="120000" y="0"/>
-                </a:lnTo>
-                <a:lnTo>
-                  <a:pt x="120000" y="120000"/>
-                </a:lnTo>
-                <a:lnTo>
-                  <a:pt x="0" y="120000"/>
-                </a:lnTo>
-                <a:close/>
-              </a:path>
-            </a:pathLst>
-          </a:custGeom>
-        </p:spPr>
-      </p:sp>
-      <p:sp>
-        <p:nvSpPr>
-          <p:cNvPr id="267" name="Google Shape;267;g38bdd1193af_0_53:notes"/>
           <p:cNvSpPr txBox="1"/>
           <p:nvPr>
             <p:ph idx="1" type="body"/>
@@ -7887,7 +7787,7 @@
       </p:sp>
       <p:pic>
         <p:nvPicPr>
-          <p:cNvPr descr="{&quot;type&quot;:&quot;gather*&quot;,&quot;aid&quot;:null,&quot;backgroundColor&quot;:&quot;#FFFFFF&quot;,&quot;id&quot;:&quot;7&quot;,&quot;font&quot;:{&quot;size&quot;:10,&quot;color&quot;:&quot;#595959&quot;,&quot;family&quot;:&quot;Arial&quot;},&quot;code&quot;:&quot;\\begin{gather*}\n{y=Ax,\\,x:m\\times1,\\,A:\\,n\\times m,\\,y:\\,n\\times1}\\\\\n{\\text{We}\\,\\text{know}\\;\\text{that}}\\\\\n{\\diff{y}{x}=A^{T}}\\\\\n{\\text{What}\\;\\text{about}\\;\\diff{y}{W}?}\\\\\n{\\text{This}\\;\\text{is}\\;\\text{a}\\;\\text{derivative}\\;\\text{of}\\;\\text{a}\\;\\text{vector}\\;\\text{against}\\;\\text{a}\\;\\text{matrix},\\,\\text{which}\\;\\text{is}\\;\\text{a}\\;\\text{hard}\\;\\text{concept}\\;\\text{to}\\;\\text{think}\\;\\text{about}.}\\\\\n{\\text{But..}\\;\\text{if}\\;\\text{we}\\;\\text{add}\\;\\text{a}\\;\\text{function}\\;\\text{that}\\;\\text{maps}\\;\\text{the}\\;\\text{vector}\\,\\text{to}\\;\\text{a}\\;\\text{scalar,}\\;\\text{then}\\;\\text{the}\\;\\text{derivative}\\;\\text{becomes}\\;\\text{tractable..}}\\\\\n{x\\to y=Ax\\to v=f\\left(y\\right)}\\\\\n{\\text{Here}\\;v\\,\\text{is}\\;\\text{a}\\;\\text{scalar..}}\\\\\n{\\text{Now}\\;\\text{we}\\;\\text{can}\\;\\text{calculate}\\;\\diff{v}{A},\\,\\text{a}\\;\\text{matrix}\\;\\text{with}\\;\\text{the}\\;\\text{same}\\;\\text{dimension}\\;\\text{as}\\;A}\t\n\\end{gather*}&quot;,&quot;backgroundColorModified&quot;:false,&quot;ts&quot;:1760223512959,&quot;cs&quot;:&quot;CUiisz3z3r6qsdC/5GOGwA==&quot;,&quot;size&quot;:{&quot;width&quot;:662,&quot;height&quot;:228}}" id="180" name="Google Shape;180;p24"/>
+          <p:cNvPr descr="{&quot;type&quot;:&quot;gather*&quot;,&quot;font&quot;:{&quot;color&quot;:&quot;#595959&quot;,&quot;size&quot;:10,&quot;family&quot;:&quot;Arial&quot;},&quot;id&quot;:&quot;7&quot;,&quot;backgroundColor&quot;:&quot;#FFFFFF&quot;,&quot;aid&quot;:null,&quot;backgroundColorModified&quot;:false,&quot;code&quot;:&quot;\\begin{gather*}\n{\\boldsymbol{y}=A\\boldsymbol{x},\\,\\boldsymbol{x}:m\\times1,\\,A:\\,n\\times m,\\,\\boldsymbol{y}:\\,n\\times1}\\\\\n{\\text{We}\\,\\text{know}\\;\\text{that}}\\\\\n{\\diff{\\boldsymbol{y}}{\\boldsymbol{x}}=A^{T}}\\\\\n{\\text{What}\\;\\text{about}\\;\\diff{y}{W}?}\\\\\n{\\text{This}\\;\\text{is}\\;\\text{a}\\;\\text{derivative}\\;\\text{of}\\;\\text{a}\\;\\text{vector}\\;\\text{against}\\;\\text{a}\\;\\text{matrix},\\,\\text{which}\\;\\text{is}\\;\\text{a}\\;\\text{hard}\\;\\text{concept}\\;\\text{to}\\;\\text{think}\\;\\text{about}.}\\\\\n{\\text{But..}\\;\\text{if}\\;\\text{we}\\;\\text{add}\\;\\text{a}\\;\\text{function}\\;\\text{that}\\;\\text{maps}\\;\\text{the}\\;\\text{vector}\\,\\text{to}\\;\\text{a}\\;\\text{scalar,}\\;\\text{then}\\;\\text{the}\\;\\text{derivative}\\;\\text{becomes}\\;\\text{tractable..}}\\\\\n{\\boldsymbol{x}\\to \\boldsymbol{y}=A\\boldsymbol{x}\\to v=f\\left(\\boldsymbol{y}\\right)}\\\\\n{\\text{Here}\\;v\\,\\text{is}\\;\\text{a}\\;\\text{scalar..}}\\\\\n{\\text{Now}\\;\\text{we}\\;\\text{can}\\;\\text{calculate}\\;\\diff{v}{A},\\,\\text{a}\\;\\text{matrix}\\;\\text{with}\\;\\text{the}\\;\\text{same}\\;\\text{dimension}\\;\\text{as}\\;A}\t\n\\end{gather*}&quot;,&quot;ts&quot;:1762637740406,&quot;cs&quot;:&quot;i2U16b0oEe2UuK5Y15h9Lg==&quot;,&quot;size&quot;:{&quot;width&quot;:662.0000000000001,&quot;height&quot;:228}}" id="180" name="Google Shape;180;p24"/>
           <p:cNvPicPr preferRelativeResize="0"/>
           <p:nvPr/>
         </p:nvPicPr>
@@ -7901,8 +7801,8 @@
         </p:blipFill>
         <p:spPr>
           <a:xfrm>
-            <a:off x="136750" y="806400"/>
-            <a:ext cx="8047073" cy="2771500"/>
+            <a:off x="417946" y="810714"/>
+            <a:ext cx="6305550" cy="2171700"/>
           </a:xfrm>
           <a:prstGeom prst="rect">
             <a:avLst/>
@@ -8025,7 +7925,7 @@
       </p:sp>
       <p:pic>
         <p:nvPicPr>
-          <p:cNvPr descr="{&quot;aid&quot;:null,&quot;id&quot;:&quot;8&quot;,&quot;backgroundColor&quot;:&quot;#FFFFFF&quot;,&quot;type&quot;:&quot;gather*&quot;,&quot;font&quot;:{&quot;size&quot;:10.5,&quot;color&quot;:&quot;#000000&quot;,&quot;family&quot;:&quot;Arial&quot;},&quot;backgroundColorModified&quot;:false,&quot;code&quot;:&quot;\\begin{gather*}\n{\\text{Let's}\\;\\text{consider}\\;\\text{the}\\;ij^{th}\\;\\text{element}\\;\\text{of}\\;\\diff{v}{A},\\,\\text{i.e.,}\\;\\diff{v}{A_{ij}}}\\\\\n{\\text{Now}\\;\\text{we}\\;\\text{have}\\;\\text{a}\\;\\text{chain..}}\\\\\n{A_{ij}\\to y\\to v,\\,\\text{here}\\;y\\,\\;\\text{is}\\;\\text{a}\\;\\text{vector}}\\\\\n{\\text{Now..}}\\\\\n{y_{i}=\\sum_{j=1}^{m}A_{ij}x_{j}}\\\\\n{\\text{Since}\\;\\text{each}\\;\\text{element}\\;\\text{of}\\;y\\,\\;\\text{is}\\;\\text{the}\\;\\text{corresponding}\\,\\text{row}\\;\\text{of}\\;\\text{A}\\;\\text{multiplied}\\;\\text{with}\\;x,\\,}\\\\\n{\\text{and}\\;\\text{other}\\;\\text{rows}\\;\\text{of}\\;\\text{A}\\,\\text{don't}\\;\\text{affect}\\;y_{i},\\,\\text{the}\\;\\text{chain}\\;\\text{above}\\;\\text{becomes}\\;\\text{a}\\;\\text{scalar}\\;\\text{chain..}\\text{}}\\\\\n{A_{ij}\\to y_{i}\\to v}\\\\\n{\\text{Now}\\;\\text{we}\\;\\text{can}\\;\\text{apply}\\;\\text{the}\\;\\text{chain}\\;\\text{rule..}}\\\\\n{\\diff{v}{A_{ij}}=\\diff{v}{y_{i}}\\diff{y_{i}}{A_{ij}}=\\diff{v}{y_{i}}\\diff{\\sum_{k=1}^{m}A_{ik}x_{k}}{A_{ij}}=\\diff{v}{y_{i}}x_{j}}\\\\\n{\\text{So..}\\;\\diff{v}{A}\\,\\text{becomes}\\;\\text{the}\\;\\text{outer}\\;\\text{product}\\;\\text{of}\\;\\text{the}\\;\\text{vectors}\\;\\diff{v}{y}\\,\\text{and}\\;x!}\\\\\n{\\diff{v}{A}=\\diff{v}{y}x^{T}\\,\\text{}}\\\\\n{\\text{Verify}\\;\\text{that}\\;\\text{the}\\;\\text{dimensions}\\;\\text{work}\\;\\text{out!}}\t\n\\end{gather*}&quot;,&quot;ts&quot;:1761864528197,&quot;cs&quot;:&quot;8H3P/qcorq4VeM9gFDYMtQ==&quot;,&quot;size&quot;:{&quot;width&quot;:537.5,&quot;height&quot;:394}}" id="187" name="Google Shape;187;p25"/>
+          <p:cNvPr descr="{&quot;code&quot;:&quot;\\begin{gather*}\n{\\text{Let's}\\;\\text{consider}\\;\\text{the}\\;ij^{th}\\;\\text{element}\\;\\text{of}\\;\\diff{v}{A},\\,\\text{i.e.,}\\;\\diff{v}{A_{ij}}}\\\\\n{\\text{Now}\\;\\text{we}\\;\\text{have}\\;\\text{a}\\;\\text{chain..}}\\\\\n{A_{ij}\\to \\boldsymbol{y}\\to v,\\,\\text{here}\\;\\boldsymbol{y}\\,\\;\\text{is}\\;\\text{a}\\;\\text{vector}}\\\\\n{\\text{Now..}}\\\\\n{y_{i}=\\sum_{j=1}^{m}A_{ij}x_{j}}\\\\\n{\\text{Since}\\;\\text{each}\\;\\text{element}\\;\\text{of}\\;y\\,\\;\\text{is}\\;\\text{the}\\;\\text{corresponding}\\,\\text{row}\\;\\text{of}\\;\\text{A}\\;\\text{multiplied}\\;\\text{with}\\;x,\\,}\\\\\n{\\text{and}\\;\\text{other}\\;\\text{rows}\\;\\text{of}\\;\\text{A}\\,\\text{don't}\\;\\text{affect}\\;y_{i},\\,\\text{the}\\;\\text{chain}\\;\\text{above}\\;\\text{becomes}\\;\\text{a}\\;\\text{scalar}\\;\\text{chain..}\\text{}}\\\\\n{A_{ij}\\to y_{i}\\to v}\\\\\n{\\text{Now}\\;\\text{we}\\;\\text{can}\\;\\text{apply}\\;\\text{the}\\;\\text{chain}\\;\\text{rule..}}\\\\\n{\\diff{v}{A_{ij}}=\\diff{v}{y_{i}}\\diff{y_{i}}{A_{ij}}=\\diff{v}{y_{i}}\\diff{\\sum_{k=1}^{m}A_{ik}x_{k}}{A_{ij}}=\\diff{v}{y_{i}}x_{j}}\\\\\n{\\text{So..}\\;\\diff{v}{A}\\,\\text{becomes}\\;\\text{the}\\;\\text{outer}\\;\\text{product}\\;\\text{of}\\;\\text{the}\\;\\text{vectors}\\;\\diff{v}{\\boldsymbol{y}}\\,\\text{and}\\;\\boldsymbol{x}!}\\\\\n{\\diff{v}{A}=\\diff{v}{\\boldsymbol{y}}\\boldsymbol{x^{T}}\\,\\text{}}\\\\\n{\\text{Verify}\\;\\text{that}\\;\\text{the}\\;\\text{dimensions}\\;\\text{work}\\;\\text{out!}}\t\n\\end{gather*}&quot;,&quot;type&quot;:&quot;gather*&quot;,&quot;font&quot;:{&quot;size&quot;:10.5,&quot;color&quot;:&quot;#000000&quot;,&quot;family&quot;:&quot;Arial&quot;},&quot;aid&quot;:null,&quot;backgroundColorModified&quot;:false,&quot;backgroundColor&quot;:&quot;#FFFFFF&quot;,&quot;id&quot;:&quot;8&quot;,&quot;ts&quot;:1762637977502,&quot;cs&quot;:&quot;gyVuWBDQeMhyfvsLz/yWvA==&quot;,&quot;size&quot;:{&quot;width&quot;:537.5,&quot;height&quot;:394}}" id="187" name="Google Shape;187;p25"/>
           <p:cNvPicPr preferRelativeResize="0"/>
           <p:nvPr/>
         </p:nvPicPr>
@@ -8161,9 +8061,59 @@
           </a:p>
         </p:txBody>
       </p:sp>
+      <p:sp>
+        <p:nvSpPr>
+          <p:cNvPr id="194" name="Google Shape;194;p26"/>
+          <p:cNvSpPr txBox="1"/>
+          <p:nvPr/>
+        </p:nvSpPr>
+        <p:spPr>
+          <a:xfrm>
+            <a:off x="579775" y="4740375"/>
+            <a:ext cx="5421600" cy="400200"/>
+          </a:xfrm>
+          <a:prstGeom prst="rect">
+            <a:avLst/>
+          </a:prstGeom>
+          <a:noFill/>
+          <a:ln>
+            <a:noFill/>
+          </a:ln>
+        </p:spPr>
+        <p:txBody>
+          <a:bodyPr anchorCtr="0" anchor="t" bIns="91425" lIns="91425" spcFirstLastPara="1" rIns="91425" wrap="square" tIns="91425">
+            <a:spAutoFit/>
+          </a:bodyPr>
+          <a:lstStyle/>
+          <a:p>
+            <a:pPr indent="0" lvl="0" marL="0" rtl="0" algn="l">
+              <a:spcBef>
+                <a:spcPts val="0"/>
+              </a:spcBef>
+              <a:spcAft>
+                <a:spcPts val="0"/>
+              </a:spcAft>
+              <a:buNone/>
+            </a:pPr>
+            <a:r>
+              <a:rPr lang="en">
+                <a:solidFill>
+                  <a:schemeClr val="dk2"/>
+                </a:solidFill>
+              </a:rPr>
+              <a:t>Code: 2_layer_network_derivatives.py</a:t>
+            </a:r>
+            <a:endParaRPr>
+              <a:solidFill>
+                <a:schemeClr val="dk2"/>
+              </a:solidFill>
+            </a:endParaRPr>
+          </a:p>
+        </p:txBody>
+      </p:sp>
       <p:pic>
         <p:nvPicPr>
-          <p:cNvPr descr="{&quot;id&quot;:&quot;9&quot;,&quot;backgroundColor&quot;:&quot;#FFFFFF&quot;,&quot;code&quot;:&quot;\\begin{gather*}\n{\\text{Now}\\;\\text{let's}\\;\\text{add}\\;\\text{another}\\;\\text{layer}\\;\\text{in}\\;\\text{front..}}\\\\\n{x\\to A\\to y\\to B\\to u\\to f\\to v}\\\\\n{\\text{As}\\;\\text{before,}\\;x:\\,m\\times1,\\,A:\\,n\\times m.\\,B:\\,k\\times n}\\\\\n{\\text{From}\\;\\text{before,}}\\\\\n{\\diff{v}{B}=\\diff{v}{u}y^{T},\\diff{v}{y}=B^{T}\\diff{v}{u}}\\\\\n{\\text{And}}\\\\\n{\\diff{v}{A}=\\diff{v}{y}x^{T}}\\\\\n{\\text{We}\\;\\text{can}\\;\\text{think}\\;\\text{of}\\;\\text{this}\\;\\text{as}\\;\\text{a}\\;2\\,\\text{layer}\\;\\text{network,}\\;\\text{where}\\;\\text{the}\\;\\text{parameters}\\;\\text{of}\\;\\text{each}\\;\\text{layer}\\;\\text{are}\\;\\text{A}\\;\\text{and}\\;\\text{B}}\\\\\n{x\\,\\text{is}\\;\\text{the}\\;\\text{input}\\;\\text{to}\\;\\text{layer}\\;\\text{1,}\\;\\text{and}\\;y\\,\\text{is}\\;\\text{the}\\;\\text{output.}\\;\\text{}}\\\\\n{y\\,\\,\\text{is}\\;\\text{the}\\;\\text{input}\\;\\text{to}\\;\\text{layer}\\;\\text{2.}\\;\\text{Output}\\;\\text{of}\\;\\text{layer}\\;\\text{2},\\,u\\;\\text{goes}\\;\\text{into}\\;\\text{function}\\;f\\,\\text{that}\\;\\text{produces}\\;\\text{a}\\;\\text{scalar}\\;\\text{value}\\;v}\\\\\n{\\text{Layer}\\;\\text{2}\\;\\text{calculates}\\;\\text{the}\\;\\text{gradient}\\;\\text{of}\\;\\text{the}\\;\\text{final}\\;\\text{output}\\;v\\,\\text{wrt}\\;\\text{its}\\;\\text{parameters}\\;B}\\\\\n{\\text{It}\\;\\text{also}\\;\\text{calculates}\\;\\text{the}\\;\\text{gradient}\\;\\text{wrt}\\;\\text{its}\\;\\text{input,}\\;\\text{which}\\;\\text{is}\\;backpropagated\\,\\text{to}\\;\\text{the}\\;\\text{previous}\\;\\text{layer}}\\\\\n{\\text{which}\\;\\text{uses}\\;\\text{it}\\;\\text{to}\\;\\text{calculate}\\;\\text{the}\\;\\text{gradient}\\;\\text{wrt}\\;\\text{its}\\;\\text{parameters}\\;\\text{and}\\;\\text{input..}\\;\\text{}}\t\n\\end{gather*}&quot;,&quot;font&quot;:{&quot;family&quot;:&quot;Arial&quot;,&quot;color&quot;:&quot;#000000&quot;,&quot;size&quot;:11},&quot;type&quot;:&quot;gather*&quot;,&quot;aid&quot;:null,&quot;backgroundColorModified&quot;:false,&quot;ts&quot;:1761865024995,&quot;cs&quot;:&quot;YgDsJi4vKp34NJxwIex2FQ==&quot;,&quot;size&quot;:{&quot;width&quot;:732.7087485564304,&quot;height&quot;:338.75587454068244}}" id="194" name="Google Shape;194;p26"/>
+          <p:cNvPr descr="{&quot;id&quot;:&quot;13&quot;,&quot;code&quot;:&quot;\\begin{gather*}\n{\\text{Now}\\;\\text{let's}\\;\\text{add}\\;\\text{another}\\;\\text{layer}\\;\\text{in}\\;\\text{front..}}\\\\\n{\\boldsymbol{x}\\to A\\to \\boldsymbol{y}\\to B\\to \\boldsymbol{u}\\to f\\to v}\\\\\n{\\text{As}\\;\\text{before,}\\;\\boldsymbol{x}:\\,m\\times1,\\,A:\\,n\\times m.\\,B:\\,k\\times n}\\\\\n{\\text{From}\\;\\text{before,}}\\\\\n{\\diff{v}{B}=\\diff{v}{\\boldsymbol{u}}\\boldsymbol{y^{T}},\\diff{v}{\\boldsymbol{y}}=B^{T}\\diff{v}{\\boldsymbol{u}}}\\\\\n{\\text{And}}\\\\\n{\\diff{v}{A}=\\diff{v}{\\boldsymbol{y}}\\boldsymbol{x^{T}}}\\\\\n{\\text{We}\\;\\text{can}\\;\\text{think}\\;\\text{of}\\;\\text{this}\\;\\text{as}\\;\\text{a}\\;2\\,\\text{layer}\\;\\text{network,}\\;\\text{where}\\;\\text{the}\\;\\text{parameters}\\;\\text{of}\\;\\text{each}\\;\\text{layer}\\;\\text{are}\\;\\text{A}\\;\\text{and}\\;\\text{B}}\\\\\n{\\boldsymbol{x}\\,\\text{is}\\;\\text{the}\\;\\text{input}\\;\\text{to}\\;\\text{layer}\\;\\text{1,}\\;\\text{and}\\;\\boldsymbol{y}\\,\\text{is}\\;\\text{the}\\;\\text{output.}\\;\\text{}}\\\\\n{\\boldsymbol{y}\\,\\,\\text{is}\\;\\text{the}\\;\\text{input}\\;\\text{to}\\;\\text{layer}\\;\\text{2.}\\;\\text{Output}\\;\\text{of}\\;\\text{layer}\\;\\text{2},\\,\\boldsymbol{u}\\;\\text{goes}\\;\\text{into}\\;\\text{function}\\;f\\,\\text{that}\\;\\text{produces}\\;\\text{a}\\;\\text{scalar}\\;\\text{value}\\;v}\\\\\n{\\text{Layer}\\;\\text{2}\\;\\text{calculates}\\;\\text{the}\\;\\text{gradient}\\;\\text{of}\\;\\text{the}\\;\\text{final}\\;\\text{output}\\;v\\,\\text{wrt}\\;\\text{its}\\;\\text{parameters}\\;B}\\\\\n{\\text{It}\\;\\text{also}\\;\\text{calculates}\\;\\text{the}\\;\\text{gradient}\\;\\text{wrt}\\;\\text{its}\\;\\text{input,}\\;\\text{which}\\;\\text{is}\\;backpropagated\\,\\text{to}\\;\\text{the}\\;\\text{previous}\\;\\text{layer}}\\\\\n{\\text{which}\\;\\text{uses}\\;\\text{it}\\;\\text{to}\\;\\text{calculate}\\;\\text{the}\\;\\text{gradient}\\;\\text{wrt}\\;\\text{its}\\;\\text{parameters}\\;\\text{and}\\;\\text{input..}\\;\\text{}}\t\n\\end{gather*}&quot;,&quot;aid&quot;:null,&quot;backgroundColor&quot;:&quot;#FFFFFF&quot;,&quot;font&quot;:{&quot;color&quot;:&quot;#000000&quot;,&quot;family&quot;:&quot;Arial&quot;,&quot;size&quot;:11},&quot;type&quot;:&quot;gather*&quot;,&quot;backgroundColorModified&quot;:false,&quot;ts&quot;:1762638101703,&quot;cs&quot;:&quot;N5njzFHWNPMBPQ6iATRiuw==&quot;,&quot;size&quot;:{&quot;width&quot;:713,&quot;height&quot;:328}}" id="195" name="Google Shape;195;p26"/>
           <p:cNvPicPr preferRelativeResize="0"/>
           <p:nvPr/>
         </p:nvPicPr>
@@ -8177,8 +8127,8 @@
         </p:blipFill>
         <p:spPr>
           <a:xfrm>
-            <a:off x="615450" y="884175"/>
-            <a:ext cx="6979051" cy="3226650"/>
+            <a:off x="381450" y="915925"/>
+            <a:ext cx="6791325" cy="3124200"/>
           </a:xfrm>
           <a:prstGeom prst="rect">
             <a:avLst/>
@@ -8189,56 +8139,6 @@
           </a:ln>
         </p:spPr>
       </p:pic>
-      <p:sp>
-        <p:nvSpPr>
-          <p:cNvPr id="195" name="Google Shape;195;p26"/>
-          <p:cNvSpPr txBox="1"/>
-          <p:nvPr/>
-        </p:nvSpPr>
-        <p:spPr>
-          <a:xfrm>
-            <a:off x="579775" y="4740375"/>
-            <a:ext cx="5421600" cy="400200"/>
-          </a:xfrm>
-          <a:prstGeom prst="rect">
-            <a:avLst/>
-          </a:prstGeom>
-          <a:noFill/>
-          <a:ln>
-            <a:noFill/>
-          </a:ln>
-        </p:spPr>
-        <p:txBody>
-          <a:bodyPr anchorCtr="0" anchor="t" bIns="91425" lIns="91425" spcFirstLastPara="1" rIns="91425" wrap="square" tIns="91425">
-            <a:spAutoFit/>
-          </a:bodyPr>
-          <a:lstStyle/>
-          <a:p>
-            <a:pPr indent="0" lvl="0" marL="0" rtl="0" algn="l">
-              <a:spcBef>
-                <a:spcPts val="0"/>
-              </a:spcBef>
-              <a:spcAft>
-                <a:spcPts val="0"/>
-              </a:spcAft>
-              <a:buNone/>
-            </a:pPr>
-            <a:r>
-              <a:rPr lang="en">
-                <a:solidFill>
-                  <a:schemeClr val="dk2"/>
-                </a:solidFill>
-              </a:rPr>
-              <a:t>Code: 2_layer_network_derivatives.py</a:t>
-            </a:r>
-            <a:endParaRPr>
-              <a:solidFill>
-                <a:schemeClr val="dk2"/>
-              </a:solidFill>
-            </a:endParaRPr>
-          </a:p>
-        </p:txBody>
-      </p:sp>
     </p:spTree>
   </p:cSld>
   <p:clrMapOvr>
@@ -8401,7 +8301,7 @@
       </p:sp>
       <p:pic>
         <p:nvPicPr>
-          <p:cNvPr descr="{&quot;backgroundColorModified&quot;:false,&quot;backgroundColor&quot;:&quot;#FFFFFF&quot;,&quot;id&quot;:&quot;10&quot;,&quot;aid&quot;:null,&quot;font&quot;:{&quot;color&quot;:&quot;#000000&quot;,&quot;size&quot;:11,&quot;family&quot;:&quot;Arial&quot;},&quot;code&quot;:&quot;\\begin{gather*}\n{\\text{Let's}\\;\\text{look}\\;\\text{at}\\;\\text{some}\\;\\text{examples}\\;\\text{of}\\;f}\\\\\n{x\\to A\\to y\\to B\\to u\\to f\\to v}\\\\\n{\\text{Example}\\;\\text{1:}}\\\\\n{f:\\,\\text{Sum}\\;\\text{function}}\\\\\n{v=\\sum_{i=1}^{k}u_{k}}\\\\\n{\\diff{v}{u}:\\,k\\times1\\,\\text{vector}}\\\\\n{\\text{Let's}\\;\\text{consider}\\;i^{th\\,}\\text{element}\\;\\text{of}\\;\\diff{v}{u}}\\\\\n{\\diff{v}{u_{i}}=1}\\\\\n{\\text{so}\\;\\diff{v}{u}=ones\\,\\left(n\\times1\\right)}\t\n\\end{gather*}&quot;,&quot;type&quot;:&quot;gather*&quot;,&quot;ts&quot;:1760305614423,&quot;cs&quot;:&quot;LoN2fiPvYipRZGBesM+EXg==&quot;,&quot;size&quot;:{&quot;width&quot;:240.5,&quot;height&quot;:305.75}}" id="203" name="Google Shape;203;p27"/>
+          <p:cNvPr descr="{&quot;backgroundColorModified&quot;:false,&quot;backgroundColor&quot;:&quot;#FFFFFF&quot;,&quot;font&quot;:{&quot;color&quot;:&quot;#000000&quot;,&quot;family&quot;:&quot;Arial&quot;,&quot;size&quot;:11},&quot;type&quot;:&quot;gather*&quot;,&quot;aid&quot;:null,&quot;id&quot;:&quot;10&quot;,&quot;code&quot;:&quot;\\begin{gather*}\n{\\text{Let's}\\;\\text{look}\\;\\text{at}\\;\\text{some}\\;\\text{examples}\\;\\text{of}\\;f}\\\\\n{\\boldsymbol{x}\\to A\\to \\boldsymbol{y}\\to B\\to \\boldsymbol{u}\\to f\\to v}\\\\\n{\\text{Example}\\;\\text{1:}}\\\\\n{f:\\,\\text{Sum}\\;\\text{function}}\\\\\n{v=\\sum_{i=1}^{k}u_{k}}\\\\\n{\\diff{v}{\\boldsymbol{u}}:\\,k\\times1\\,\\text{vector}}\\\\\n{\\text{Let's}\\;\\text{consider}\\;i^{th\\,}\\text{element}\\;\\text{of}\\;\\diff{v}{\\boldsymbol{u}}}\\\\\n{\\diff{v}{u_{i}}=1}\\\\\n{\\text{so}\\;\\diff{v}{\\boldsymbol{u}}=ones\\,\\left(n\\times1\\right)}\t\n\\end{gather*}&quot;,&quot;ts&quot;:1762638165845,&quot;cs&quot;:&quot;VbHhF5Si9/YQphdgAfBNPA==&quot;,&quot;size&quot;:{&quot;width&quot;:240.5,&quot;height&quot;:305.75}}" id="203" name="Google Shape;203;p27"/>
           <p:cNvPicPr preferRelativeResize="0"/>
           <p:nvPr/>
         </p:nvPicPr>
@@ -8429,7 +8329,7 @@
       </p:pic>
       <p:pic>
         <p:nvPicPr>
-          <p:cNvPr descr="{&quot;aid&quot;:null,&quot;code&quot;:&quot;\\begin{gather*}\n{\\text{Example}\\;\\text{2:}}\\\\\n{f:\\,\\text{Norm}}\\\\\n{v=\\frac{1}{2}\\sum_{i=1}^{k}u_{k}^{2}}\\\\\n{\\diff{v}{u_{i}}=u_{i}}\\\\\n{\\text{so}\\;\\diff{v}{u}=u}\t\n\\end{gather*}&quot;,&quot;backgroundColorModified&quot;:false,&quot;font&quot;:{&quot;size&quot;:11,&quot;family&quot;:&quot;Arial&quot;,&quot;color&quot;:&quot;#000000&quot;},&quot;type&quot;:&quot;gather*&quot;,&quot;id&quot;:&quot;10&quot;,&quot;backgroundColor&quot;:&quot;#FFFFFF&quot;,&quot;ts&quot;:1760305994868,&quot;cs&quot;:&quot;0CnibtYFpyvKYn0aLUIA2w==&quot;,&quot;size&quot;:{&quot;width&quot;:94.33333333333333,&quot;height&quot;:179.33333333333334}}" id="204" name="Google Shape;204;p27"/>
+          <p:cNvPr descr="{&quot;aid&quot;:null,&quot;backgroundColorModified&quot;:false,&quot;code&quot;:&quot;\\begin{gather*}\n{\\text{Example}\\;\\text{2:}}\\\\\n{f:\\,\\text{Norm}}\\\\\n{v=\\frac{1}{2}\\sum_{i=1}^{k}u_{k}^{2}}\\\\\n{\\diff{v}{u_{i}}=u_{i}}\\\\\n{\\text{so}\\;\\diff{v}{\\boldsymbol{u}}=\\boldsymbol{u}}\t\n\\end{gather*}&quot;,&quot;type&quot;:&quot;gather*&quot;,&quot;backgroundColor&quot;:&quot;#FFFFFF&quot;,&quot;font&quot;:{&quot;family&quot;:&quot;Arial&quot;,&quot;size&quot;:13,&quot;color&quot;:&quot;#000000&quot;},&quot;id&quot;:&quot;10&quot;,&quot;ts&quot;:1762638198040,&quot;cs&quot;:&quot;+yP3/dbMF0n6CjToIuFVYA==&quot;,&quot;size&quot;:{&quot;width&quot;:111.5,&quot;height&quot;:211.83333333333334}}" id="204" name="Google Shape;204;p27"/>
           <p:cNvPicPr preferRelativeResize="0"/>
           <p:nvPr/>
         </p:nvPicPr>
@@ -8443,8 +8343,8 @@
         </p:blipFill>
         <p:spPr>
           <a:xfrm>
-            <a:off x="4212225" y="1005275"/>
-            <a:ext cx="1077174" cy="2047776"/>
+            <a:off x="4212225" y="1005928"/>
+            <a:ext cx="1062038" cy="2017713"/>
           </a:xfrm>
           <a:prstGeom prst="rect">
             <a:avLst/>
@@ -8985,7 +8885,7 @@
       </p:sp>
       <p:pic>
         <p:nvPicPr>
-          <p:cNvPr descr="{&quot;code&quot;:&quot;\\begin{gather*}\n{\\text{Now}\\;\\text{lets}\\;\\text{add}\\;\\text{a}\\;\\text{bias}\\;\\text{term}}\\\\\n{\\text{So,}\\;y=Ax+b;\\,x:m\\times1,\\,A:\\,n\\times m,\\,b:\\,n\\times1}\\\\\n{L=f\\left(y\\right)\\,}\\\\\n{\\text{We}\\;\\text{want}\\;\\diff{L}{b}}\\\\\n{\\text{Let's}\\;\\text{consider}\\;i^{th\\,}\\text{element}\\;\\text{of}\\,\\diff{L}{b}}\\\\\n{\\text{It}\\;\\text{is}\\;\\text{easy}\\;\\text{to}\\;\\text{see}\\;\\text{that}\\;b_{i}\\,\\text{only}\\;\\text{affects}\\;y_{i},\\,\\text{so}\\;\\text{we}\\;\\text{get}\\;\\text{a}\\;\\text{scalar}\\;\\text{chain}\\;\\text{rule}}\\\\\n{b_{i}\\to y_{i}\\to L}\\\\\n{\\diff{L}{b_{i}}=\\diff{L}{y_{i}}\\diff{y_{i}}{b_{i}}=\\diff{L}{y_{i}}}\t\n\\end{gather*}&quot;,&quot;type&quot;:&quot;gather*&quot;,&quot;backgroundColorModified&quot;:false,&quot;backgroundColor&quot;:&quot;#FFFFFF&quot;,&quot;aid&quot;:null,&quot;font&quot;:{&quot;size&quot;:12,&quot;color&quot;:&quot;#000000&quot;,&quot;family&quot;:&quot;Arial&quot;},&quot;id&quot;:&quot;11&quot;,&quot;ts&quot;:1760307980441,&quot;cs&quot;:&quot;+MCI3wTTaXcxbjPD5qWmgQ==&quot;,&quot;size&quot;:{&quot;width&quot;:536,&quot;height&quot;:252.5}}" id="221" name="Google Shape;221;p28"/>
+          <p:cNvPr descr="{&quot;aid&quot;:null,&quot;code&quot;:&quot;\\begin{gather*}\n{\\text{Now}\\;\\text{lets}\\;\\text{add}\\;\\text{a}\\;\\text{bias}\\;\\text{term}}\\\\\n{\\text{So,}\\;\\boldsymbol{y}=A\\boldsymbol{x}+b;\\,\\boldsymbol{x}:m\\times1,\\,A:\\,n\\times m,\\,\\boldsymbol{b}:\\,n\\times1}\\\\\n{L=f\\left(\\boldsymbol{y}\\right)\\,}\\\\\n{\\text{We}\\;\\text{want}\\;\\diff{L}{\\boldsymbol{b}}}\\\\\n{\\text{Let's}\\;\\text{consider}\\;i^{th\\,}\\text{element}\\;\\text{of}\\,\\diff{L}{\\boldsymbol{b}}}\\\\\n{\\text{It}\\;\\text{is}\\;\\text{easy}\\;\\text{to}\\;\\text{see}\\;\\text{that}\\;b_{i}\\,\\text{only}\\;\\text{affects}\\;y_{i},\\,\\text{so}\\;\\text{we}\\;\\text{get}\\;\\text{a}\\;\\text{scalar}\\;\\text{chain}\\;\\text{rule}}\\\\\n{b_{i}\\to y_{i}\\to L}\\\\\n{\\diff{L}{b_{i}}=\\diff{L}{y_{i}}\\diff{y_{i}}{b_{i}}=\\diff{L}{y_{i}}\\,\\because\\diff{y_{i}}{b_{i}}=1}\t\n\\end{gather*}&quot;,&quot;backgroundColorModified&quot;:false,&quot;type&quot;:&quot;gather*&quot;,&quot;font&quot;:{&quot;family&quot;:&quot;Arial&quot;,&quot;size&quot;:12,&quot;color&quot;:&quot;#000000&quot;},&quot;backgroundColor&quot;:&quot;#FFFFFF&quot;,&quot;id&quot;:&quot;11&quot;,&quot;ts&quot;:1762638331327,&quot;cs&quot;:&quot;Kefnvxvd6ejLTnmE2aVeWw==&quot;,&quot;size&quot;:{&quot;width&quot;:536,&quot;height&quot;:252.5}}" id="221" name="Google Shape;221;p28"/>
           <p:cNvPicPr preferRelativeResize="0"/>
           <p:nvPr/>
         </p:nvPicPr>
@@ -10794,172 +10694,6 @@
 </p:sld>
 </file>
 
-<file path=ppt/slides/slide19.xml><?xml version="1.0" encoding="utf-8"?>
-<p:sld xmlns:a="http://schemas.openxmlformats.org/drawingml/2006/main" xmlns:r="http://schemas.openxmlformats.org/officeDocument/2006/relationships" xmlns:mc="http://schemas.openxmlformats.org/markup-compatibility/2006" xmlns:mv="urn:schemas-microsoft-com:mac:vml" xmlns:p="http://schemas.openxmlformats.org/presentationml/2006/main" xmlns:c="http://schemas.openxmlformats.org/drawingml/2006/chart" xmlns:dgm="http://schemas.openxmlformats.org/drawingml/2006/diagram" xmlns:o="urn:schemas-microsoft-com:office:office" xmlns:v="urn:schemas-microsoft-com:vml" xmlns:pvml="urn:schemas-microsoft-com:office:powerpoint" xmlns:com="http://schemas.openxmlformats.org/drawingml/2006/compatibility" xmlns:p14="http://schemas.microsoft.com/office/powerpoint/2010/main" xmlns:p15="http://schemas.microsoft.com/office/powerpoint/2012/main" xmlns:ahyp="http://schemas.microsoft.com/office/drawing/2018/hyperlinkcolor">
-  <p:cSld>
-    <p:spTree>
-      <p:nvGrpSpPr>
-        <p:cNvPr id="268" name="Shape 268"/>
-        <p:cNvGrpSpPr/>
-        <p:nvPr/>
-      </p:nvGrpSpPr>
-      <p:grpSpPr>
-        <a:xfrm>
-          <a:off x="0" y="0"/>
-          <a:ext cx="0" cy="0"/>
-          <a:chOff x="0" y="0"/>
-          <a:chExt cx="0" cy="0"/>
-        </a:xfrm>
-      </p:grpSpPr>
-      <p:sp>
-        <p:nvSpPr>
-          <p:cNvPr id="269" name="Google Shape;269;p31"/>
-          <p:cNvSpPr txBox="1"/>
-          <p:nvPr>
-            <p:ph idx="4294967295" type="title"/>
-          </p:nvPr>
-        </p:nvSpPr>
-        <p:spPr>
-          <a:xfrm>
-            <a:off x="259350" y="157250"/>
-            <a:ext cx="8520600" cy="572700"/>
-          </a:xfrm>
-          <a:prstGeom prst="rect">
-            <a:avLst/>
-          </a:prstGeom>
-        </p:spPr>
-        <p:txBody>
-          <a:bodyPr anchorCtr="0" anchor="t" bIns="91425" lIns="91425" spcFirstLastPara="1" rIns="91425" wrap="square" tIns="91425">
-            <a:normAutofit fontScale="90000"/>
-          </a:bodyPr>
-          <a:lstStyle/>
-          <a:p>
-            <a:pPr indent="0" lvl="0" marL="0" rtl="0" algn="l">
-              <a:spcBef>
-                <a:spcPts val="0"/>
-              </a:spcBef>
-              <a:spcAft>
-                <a:spcPts val="0"/>
-              </a:spcAft>
-              <a:buNone/>
-            </a:pPr>
-            <a:r>
-              <a:rPr lang="en"/>
-              <a:t>Derivative of a vector against a matrix</a:t>
-            </a:r>
-            <a:endParaRPr/>
-          </a:p>
-        </p:txBody>
-      </p:sp>
-      <p:sp>
-        <p:nvSpPr>
-          <p:cNvPr id="270" name="Google Shape;270;p31"/>
-          <p:cNvSpPr txBox="1"/>
-          <p:nvPr/>
-        </p:nvSpPr>
-        <p:spPr>
-          <a:xfrm>
-            <a:off x="381450" y="806388"/>
-            <a:ext cx="3013800" cy="461700"/>
-          </a:xfrm>
-          <a:prstGeom prst="rect">
-            <a:avLst/>
-          </a:prstGeom>
-          <a:noFill/>
-          <a:ln>
-            <a:noFill/>
-          </a:ln>
-        </p:spPr>
-        <p:txBody>
-          <a:bodyPr anchorCtr="0" anchor="t" bIns="91425" lIns="91425" spcFirstLastPara="1" rIns="91425" wrap="square" tIns="91425">
-            <a:spAutoFit/>
-          </a:bodyPr>
-          <a:lstStyle/>
-          <a:p>
-            <a:pPr indent="0" lvl="0" marL="0" rtl="0" algn="l">
-              <a:spcBef>
-                <a:spcPts val="0"/>
-              </a:spcBef>
-              <a:spcAft>
-                <a:spcPts val="0"/>
-              </a:spcAft>
-              <a:buNone/>
-            </a:pPr>
-            <a:r>
-              <a:t/>
-            </a:r>
-            <a:endParaRPr sz="1800">
-              <a:solidFill>
-                <a:schemeClr val="dk2"/>
-              </a:solidFill>
-            </a:endParaRPr>
-          </a:p>
-        </p:txBody>
-      </p:sp>
-      <p:pic>
-        <p:nvPicPr>
-          <p:cNvPr descr="{&quot;aid&quot;:null,&quot;code&quot;:&quot;\\begin{gather*}\n{\\text{Let's}\\;\\text{consider}\\;\\text{the}\\;ij^{th}\\;\\text{element}\\;\\text{of}\\;\\diff{v}{A},\\,\\text{i.e.,}\\;\\diff{v}{A_{ij}}}\\\\\n{\\text{Now}\\;\\text{we}\\;\\text{have}\\;\\text{a}\\;\\text{chain..}}\\\\\n{A_{ij}\\to y\\to v,\\,\\text{here}\\;y\\,\\;\\text{is}\\;\\text{a}\\;\\text{vector}}\\\\\n{\\text{Now..}}\\\\\n{y_{i}=\\sum_{j=1}^{m}A_{ij}x_{j}}\\\\\n{\\text{Since}\\;\\text{each}\\;\\text{element}\\;\\text{of}\\;y\\,\\;\\text{is}\\;\\text{the}\\;\\text{corresponding}\\,\\text{row}\\;\\text{of}\\;\\text{A}\\;\\text{multiplied}\\;\\text{with}\\;x,\\,}\\\\\n{\\text{and}\\;\\text{other}\\;\\text{rows}\\;\\text{of}\\;\\text{A}\\,\\text{don't}\\;\\text{affect}\\;y_{i},\\,\\text{the}\\;\\text{chain}\\;\\text{above}\\;\\text{becomes}\\;\\text{a}\\;\\text{scalar}\\;\\text{chain..}\\text{}}\\\\\n{A_{ij}\\to y_{i}\\to v}\\\\\n{\\text{Now}\\;\\text{we}\\;\\text{can}\\;\\text{apply}\\;\\text{the}\\;\\text{chain}\\;\\text{rule..}}\\\\\n{\\diff{v}{A_{ij}}=\\diff{v}{y_{i}}\\diff{y_{i}}{A_{ij}}=\\diff{v}{y_{i}}\\diff{\\sum_{j=1}^{m}A_{ij}x_{j}}{A_{ij}}=\\diff{v}{y_{i}}x_{j}}\\\\\n{\\text{So..}\\;\\diff{v}{A}\\,\\text{becomes}\\;\\text{the}\\;\\text{outer}\\;\\text{product}\\;\\text{of}\\;\\text{the}\\;\\text{vectors}\\;\\diff{v}{y}\\,\\text{and}\\;x!}\\\\\n{\\diff{v}{A}=\\diff{v}{y}x^{T}\\,\\text{}}\\\\\n{\\text{Verify}\\;\\text{that}\\;\\text{the}\\;\\text{dimensions}\\;\\text{work}\\;\\text{out!}}\t\n\\end{gather*}&quot;,&quot;font&quot;:{&quot;size&quot;:10.5,&quot;family&quot;:&quot;Arial&quot;,&quot;color&quot;:&quot;#000000&quot;},&quot;backgroundColorModified&quot;:false,&quot;backgroundColor&quot;:&quot;#FFFFFF&quot;,&quot;type&quot;:&quot;gather*&quot;,&quot;id&quot;:&quot;8&quot;,&quot;ts&quot;:1760275169609,&quot;cs&quot;:&quot;l2j0dH2bjN2hjF9nIGzL3Q==&quot;,&quot;size&quot;:{&quot;width&quot;:557.3779509186352,&quot;height&quot;:409.9841679790026}}" id="271" name="Google Shape;271;p31"/>
-          <p:cNvPicPr preferRelativeResize="0"/>
-          <p:nvPr/>
-        </p:nvPicPr>
-        <p:blipFill>
-          <a:blip r:embed="rId3">
-            <a:alphaModFix/>
-          </a:blip>
-          <a:stretch>
-            <a:fillRect/>
-          </a:stretch>
-        </p:blipFill>
-        <p:spPr>
-          <a:xfrm>
-            <a:off x="553150" y="806400"/>
-            <a:ext cx="5546225" cy="4079576"/>
-          </a:xfrm>
-          <a:prstGeom prst="rect">
-            <a:avLst/>
-          </a:prstGeom>
-          <a:noFill/>
-          <a:ln>
-            <a:noFill/>
-          </a:ln>
-        </p:spPr>
-      </p:pic>
-      <p:pic>
-        <p:nvPicPr>
-          <p:cNvPr descr="{&quot;id&quot;:&quot;9&quot;,&quot;backgroundColor&quot;:&quot;#FFFFFF&quot;,&quot;code&quot;:&quot;\\begin{gather*}\n{\\text{Now}\\;\\text{let's}\\;\\text{add}\\;\\text{another}\\;\\text{layer}\\;\\text{in}\\;\\text{front..}}\\\\\n{x\\to A\\to y\\to B\\to u\\to f\\to v}\\\\\n{\\text{As}\\;\\text{before,}\\;x:\\,m\\times1,\\,A:\\,n\\times m.\\,B:\\,k\\times n}\\\\\n{\\text{From}\\;\\text{before,}}\\\\\n{\\diff{v}{B}=\\diff{v}{u}y^{T},\\diff{v}{y}=B^{T}\\diff{v}{u}}\\\\\n{\\text{And}}\\\\\n{\\diff{v}{A}=\\diff{v}{y}x^{T}}\\\\\n{\\text{We}\\;\\text{can}\\;\\text{think}\\;\\text{of}\\;\\text{this}\\;\\text{as}\\;\\text{a}\\;2\\,\\text{layer}\\;\\text{network,}\\;\\text{where}\\;\\text{the}\\;\\text{parameters}\\;\\text{of}\\;\\text{each}\\;\\text{layer}\\;\\text{are}\\;\\text{A}\\;\\text{and}\\;\\text{B}}\\\\\n{x\\,\\text{is}\\;\\text{the}\\;\\text{input}\\;\\text{to}\\;\\text{layer}\\;\\text{1,}\\;\\text{and}\\;y\\,\\text{is}\\;\\text{the}\\;\\text{output.}\\;\\text{}}\\\\\n{y\\,\\,\\text{is}\\;\\text{the}\\;\\text{input}\\;\\text{to}\\;\\text{layer}\\;\\text{2.}\\;\\text{Output}\\;\\text{of}\\;\\text{layer}\\;\\text{2},\\,u\\;\\text{goes}\\;\\text{into}\\;\\text{function}\\;f\\,\\text{that}\\;\\text{produces}\\;\\text{a}\\;\\text{scalar}\\;\\text{value}\\;v}\\\\\n{\\text{Layer}\\;\\text{2}\\;\\text{calculates}\\;\\text{the}\\;\\text{gradient}\\;\\text{of}\\;\\text{the}\\;\\text{final}\\;\\text{output}\\;v\\,\\text{wrt}\\;\\text{its}\\;\\text{parameters}\\;B}\\\\\n{\\text{It}\\;\\text{also}\\;\\text{calculates}\\;\\text{the}\\;\\text{gradient}\\;\\text{wrt}\\;\\text{its}\\;\\text{input,}\\;\\text{which}\\;\\text{is}\\;backpropagated\\,\\text{to}\\;\\text{the}\\;\\text{previous}\\;\\text{layer}}\\\\\n{\\text{which}\\;\\text{uses}\\;\\text{it}\\;\\text{to}\\;\\text{calculate}\\;\\text{the}\\;\\text{gradient}\\;\\text{wrt}\\;\\text{its}\\;\\text{parameters}\\;\\text{and}\\;\\text{input..}\\;\\text{}}\t\n\\end{gather*}&quot;,&quot;font&quot;:{&quot;family&quot;:&quot;Arial&quot;,&quot;color&quot;:&quot;#000000&quot;,&quot;size&quot;:10.5},&quot;type&quot;:&quot;gather*&quot;,&quot;aid&quot;:null,&quot;backgroundColorModified&quot;:false,&quot;ts&quot;:1760276974089,&quot;cs&quot;:&quot;w4DnoI+cLB2zQV5+266eWQ==&quot;,&quot;size&quot;:{&quot;width&quot;:677,&quot;height&quot;:313}}" id="272" name="Google Shape;272;p31"/>
-          <p:cNvPicPr preferRelativeResize="0"/>
-          <p:nvPr/>
-        </p:nvPicPr>
-        <p:blipFill>
-          <a:blip r:embed="rId4">
-            <a:alphaModFix/>
-          </a:blip>
-          <a:stretch>
-            <a:fillRect/>
-          </a:stretch>
-        </p:blipFill>
-        <p:spPr>
-          <a:xfrm>
-            <a:off x="4572000" y="2571750"/>
-            <a:ext cx="6448425" cy="2981325"/>
-          </a:xfrm>
-          <a:prstGeom prst="rect">
-            <a:avLst/>
-          </a:prstGeom>
-          <a:noFill/>
-          <a:ln>
-            <a:noFill/>
-          </a:ln>
-        </p:spPr>
-      </p:pic>
-    </p:spTree>
-  </p:cSld>
-  <p:clrMapOvr>
-    <a:masterClrMapping/>
-  </p:clrMapOvr>
-</p:sld>
-</file>
-
 <file path=ppt/slides/slide2.xml><?xml version="1.0" encoding="utf-8"?>
 <p:sld xmlns:a="http://schemas.openxmlformats.org/drawingml/2006/main" xmlns:r="http://schemas.openxmlformats.org/officeDocument/2006/relationships" xmlns:mc="http://schemas.openxmlformats.org/markup-compatibility/2006" xmlns:mv="urn:schemas-microsoft-com:mac:vml" xmlns:p="http://schemas.openxmlformats.org/presentationml/2006/main" xmlns:c="http://schemas.openxmlformats.org/drawingml/2006/chart" xmlns:dgm="http://schemas.openxmlformats.org/drawingml/2006/diagram" xmlns:o="urn:schemas-microsoft-com:office:office" xmlns:v="urn:schemas-microsoft-com:vml" xmlns:pvml="urn:schemas-microsoft-com:office:powerpoint" xmlns:com="http://schemas.openxmlformats.org/drawingml/2006/compatibility" xmlns:p14="http://schemas.microsoft.com/office/powerpoint/2010/main" xmlns:p15="http://schemas.microsoft.com/office/powerpoint/2012/main" xmlns:ahyp="http://schemas.microsoft.com/office/drawing/2018/hyperlinkcolor">
   <p:cSld>
@@ -11466,7 +11200,7 @@
         <p:spPr>
           <a:xfrm>
             <a:off x="480050" y="1195250"/>
-            <a:ext cx="6747300" cy="1569900"/>
+            <a:ext cx="6747300" cy="2124000"/>
           </a:xfrm>
           <a:prstGeom prst="rect">
             <a:avLst/>
@@ -11501,7 +11235,7 @@
                   <a:schemeClr val="dk2"/>
                 </a:solidFill>
               </a:rPr>
-              <a:t>Introduction to multivariate functions</a:t>
+              <a:t>Introduction to multi-valued functions of many variables</a:t>
             </a:r>
             <a:endParaRPr sz="1800">
               <a:solidFill>
@@ -11529,15 +11263,7 @@
                   <a:schemeClr val="dk2"/>
                 </a:solidFill>
               </a:rPr>
-              <a:t>Geometric </a:t>
-            </a:r>
-            <a:r>
-              <a:rPr lang="en" sz="1800">
-                <a:solidFill>
-                  <a:schemeClr val="dk2"/>
-                </a:solidFill>
-              </a:rPr>
-              <a:t>interpretation</a:t>
+              <a:t>Numerator and Denominator notation</a:t>
             </a:r>
             <a:endParaRPr sz="1800">
               <a:solidFill>
@@ -11565,7 +11291,7 @@
                   <a:schemeClr val="dk2"/>
                 </a:solidFill>
               </a:rPr>
-              <a:t>Chain rule in a computational graph</a:t>
+              <a:t>Extension of chain rule to multivariate functions</a:t>
             </a:r>
             <a:endParaRPr sz="1800">
               <a:solidFill>
@@ -11593,23 +11319,63 @@
                   <a:schemeClr val="dk2"/>
                 </a:solidFill>
               </a:rPr>
-              <a:t>Using partial </a:t>
-            </a:r>
+              <a:t>Derivatives of matrix operations</a:t>
+            </a:r>
+            <a:endParaRPr sz="1800">
+              <a:solidFill>
+                <a:schemeClr val="dk2"/>
+              </a:solidFill>
+            </a:endParaRPr>
+          </a:p>
+          <a:p>
+            <a:pPr indent="-342900" lvl="0" marL="457200" rtl="0" algn="l">
+              <a:spcBef>
+                <a:spcPts val="0"/>
+              </a:spcBef>
+              <a:spcAft>
+                <a:spcPts val="0"/>
+              </a:spcAft>
+              <a:buClr>
+                <a:schemeClr val="dk2"/>
+              </a:buClr>
+              <a:buSzPts val="1800"/>
+              <a:buChar char="-"/>
+            </a:pPr>
             <a:r>
               <a:rPr lang="en" sz="1800">
                 <a:solidFill>
                   <a:schemeClr val="dk2"/>
                 </a:solidFill>
               </a:rPr>
-              <a:t>derivatives</a:t>
-            </a:r>
+              <a:t>Solving linear regression using matrix math</a:t>
+            </a:r>
+            <a:endParaRPr sz="1800">
+              <a:solidFill>
+                <a:schemeClr val="dk2"/>
+              </a:solidFill>
+            </a:endParaRPr>
+          </a:p>
+          <a:p>
+            <a:pPr indent="-342900" lvl="0" marL="457200" rtl="0" algn="l">
+              <a:spcBef>
+                <a:spcPts val="0"/>
+              </a:spcBef>
+              <a:spcAft>
+                <a:spcPts val="0"/>
+              </a:spcAft>
+              <a:buClr>
+                <a:schemeClr val="dk2"/>
+              </a:buClr>
+              <a:buSzPts val="1800"/>
+              <a:buChar char="-"/>
+            </a:pPr>
             <a:r>
               <a:rPr lang="en" sz="1800">
                 <a:solidFill>
                   <a:schemeClr val="dk2"/>
                 </a:solidFill>
               </a:rPr>
-              <a:t> to solve linear regression</a:t>
+              <a:t>Derivation of backpropagation</a:t>
             </a:r>
             <a:endParaRPr sz="1800">
               <a:solidFill>

</xml_diff>